<commit_message>
Add author identity to 6G talk deck, PPTX, and handout
Set the presenting byline on all audience-facing artifacts:
Dr. Markkandan S, Associate Professor, School of Electronics Engineering,
Vellore Institute of Technology, Chennai — markkandan.s@vit.ac.in.

- beamer: title-slide author/institute + closing contact slide
- pptx: title slide + "Thank you" contact slide (content.py); deck rebuilt,
  equation/TikZ PNGs re-rendered
- handout: byline line under the title (still exactly 2 pages)

Replaces the placeholder gmail contact with the professional address on every
deliverable. All three rebuilt: Beamer 86 pp, PPTX 86 slides, handout 2 pp.

Co-Authored-By: Claude Fable 5 <noreply@anthropic.com>
</commit_message>
<xml_diff>
--- a/6g-talk/pptx/6g_talk.pptx
+++ b/6g-talk/pptx/6g_talk.pptx
@@ -9739,7 +9739,7 @@
                 </a:solidFill>
                 <a:latin typeface="Arial"/>
               </a:rPr>
-              <a:t>Dr. Markkandan S</a:t>
+              <a:t>Dr. Markkandan S  ·  Associate Professor</a:t>
             </a:r>
           </a:p>
           <a:p>
@@ -9751,7 +9751,7 @@
                 </a:solidFill>
                 <a:latin typeface="Arial"/>
               </a:rPr>
-              <a:t>School of Electronics Engineering, VIT</a:t>
+              <a:t>School of Electronics Engineering, Vellore Institute of Technology, Chennai  ·  markkandan.s@vit.ac.in</a:t>
             </a:r>
           </a:p>
           <a:p>
@@ -34866,7 +34866,7 @@
                 </a:solidFill>
                 <a:latin typeface="Arial"/>
               </a:rPr>
-              <a:t>Questions — now, or anytime:</a:t>
+              <a:t>Dr. Markkandan S  ·  Associate Professor, SENSE, VIT Chennai</a:t>
             </a:r>
           </a:p>
           <a:p>
@@ -34878,7 +34878,7 @@
                 </a:solidFill>
                 <a:latin typeface="Arial"/>
               </a:rPr>
-              <a:t>ipresearch7@gmail.com</a:t>
+              <a:t>markkandan.s@vit.ac.in</a:t>
             </a:r>
           </a:p>
           <a:p>

</xml_diff>